<commit_message>
v3 pitch: animated stakes charts and a closing trailer slide
The monthly users line now draws itself and the users-by-function bars
grow, then light up one by one with the value enlarged and bold (GIFs
that also play in Google Slides). A final slide holds a placeholder for
the trailer video, and the speaker notes move the trailer cue there.

Co-Authored-By: Claude Opus 5.5 <noreply@anthropic.com>
Claude-Session: https://claude.ai/code/session_01HdxEbeqqWM97gKbcNqpjAq
</commit_message>
<xml_diff>
--- a/erm-migration/docs/ERM-Migration-Pitch-v3.pptx
+++ b/erm-migration/docs/ERM-Migration-Pitch-v3.pptx
@@ -16,9 +16,10 @@
     <p:sldId id="264" r:id="rId10"/>
     <p:sldId id="265" r:id="rId11"/>
     <p:sldId id="266" r:id="rId12"/>
+    <p:sldId id="267" r:id="rId13"/>
   </p:sldIdLst>
   <p:notesMasterIdLst>
-    <p:notesMasterId r:id="rId13"/>
+    <p:notesMasterId r:id="rId14"/>
   </p:notesMasterIdLst>
   <p:sldSz cx="12192000" cy="6858000"/>
   <p:notesSz cx="6858000" cy="12192000"/>
@@ -117,7 +118,7 @@
   <p:extLst>
     <p:ext uri="{521415D9-36F7-43E2-AB2F-B90AF26B5E84}">
       <p14:sectionLst xmlns:p14="http://schemas.microsoft.com/office/powerpoint/2010/main">
-        <p14:section name="Context" id="{74acef77-42fe-5d1d-5426-c8099ced7e3d}">
+        <p14:section name="Context" id="{83b98163-8de8-7538-4933-e60bb01742b6}">
           <p14:sldIdLst>
             <p14:sldId id="256"/>
             <p14:sldId id="257"/>
@@ -126,22 +127,23 @@
             <p14:sldId id="260"/>
           </p14:sldIdLst>
         </p14:section>
-        <p14:section name="Stakes" id="{5339293c-92ff-7bbd-baec-998a96db5c81}">
+        <p14:section name="Stakes" id="{2885cb0c-3426-ed8b-be78-117e48e7f1b5}">
           <p14:sldIdLst>
             <p14:sldId id="261"/>
           </p14:sldIdLst>
         </p14:section>
-        <p14:section name="Transformation" id="{9c753879-8158-37f2-e115-7edee465dcf6}">
+        <p14:section name="Transformation" id="{430e8b60-58c9-bb00-6768-38da733dde31}">
           <p14:sldIdLst>
             <p14:sldId id="262"/>
             <p14:sldId id="263"/>
             <p14:sldId id="264"/>
           </p14:sldIdLst>
         </p14:section>
-        <p14:section name="Fit and next" id="{2635bc02-4200-3942-3a39-37dc309f44a5}">
+        <p14:section name="Fit and next" id="{b790d8d2-6745-f5f4-b944-6e497fedb133}">
           <p14:sldIdLst>
             <p14:sldId id="265"/>
             <p14:sldId id="266"/>
+            <p14:sldId id="267"/>
           </p14:sldIdLst>
         </p14:section>
       </p14:sectionLst>
@@ -151,643 +153,6 @@
     </p:ext>
   </p:extLst>
 </p:presentation>
-</file>
-
-<file path=ppt/charts/chart1.xml><?xml version="1.0" encoding="utf-8"?>
-<c:chartSpace xmlns:c="http://schemas.openxmlformats.org/drawingml/2006/chart" xmlns:a="http://schemas.openxmlformats.org/drawingml/2006/main" xmlns:r="http://schemas.openxmlformats.org/officeDocument/2006/relationships">
-  <c:date1904 val="0"/>
-  <c:roundedCorners val="1"/>
-  <c:chart>
-    <c:autoTitleDeleted val="1"/>
-    <c:plotArea>
-      <c:layout/>
-      <c:lineChart>
-        <c:varyColors val="0"/>
-        <c:ser>
-          <c:idx val="0"/>
-          <c:order val="0"/>
-          <c:tx>
-            <c:strRef>
-              <c:f>Sheet1!$B$1</c:f>
-              <c:strCache>
-                <c:ptCount val="1"/>
-                <c:pt idx="0">
-                  <c:v>Unique users</c:v>
-                </c:pt>
-              </c:strCache>
-            </c:strRef>
-          </c:tx>
-          <c:spPr>
-            <a:solidFill>
-              <a:srgbClr val="0085CA"/>
-            </a:solidFill>
-            <a:ln w="25400" cap="flat">
-              <a:solidFill>
-                <a:srgbClr val="0085CA"/>
-              </a:solidFill>
-              <a:prstDash val="solid"/>
-              <a:round/>
-            </a:ln>
-            <a:effectLst/>
-          </c:spPr>
-          <c:invertIfNegative val="0"/>
-          <c:dLbls>
-            <c:numFmt formatCode="#,##0" sourceLinked="0"/>
-            <c:txPr>
-              <a:bodyPr/>
-              <a:lstStyle/>
-              <a:p>
-                <a:pPr>
-                  <a:defRPr b="0" i="0" strike="noStrike" sz="1200" u="none">
-                    <a:solidFill>
-                      <a:srgbClr val="000000"/>
-                    </a:solidFill>
-                    <a:latin typeface="Arial"/>
-                  </a:defRPr>
-                </a:pPr>
-              </a:p>
-            </c:txPr>
-            <c:showLegendKey val="0"/>
-            <c:showVal val="0"/>
-            <c:showCatName val="0"/>
-            <c:showSerName val="0"/>
-            <c:showPercent val="0"/>
-            <c:showBubbleSize val="0"/>
-            <c:showLeaderLines val="0"/>
-          </c:dLbls>
-          <c:marker>
-            <c:symbol val="circle"/>
-            <c:size val="4"/>
-            <c:spPr>
-              <a:solidFill>
-                <a:srgbClr val="0085CA"/>
-              </a:solidFill>
-              <a:ln w="9525" cap="flat">
-                <a:solidFill>
-                  <a:srgbClr val="0085CA"/>
-                </a:solidFill>
-                <a:prstDash val="solid"/>
-                <a:round/>
-              </a:ln>
-              <a:effectLst/>
-            </c:spPr>
-          </c:marker>
-          <c:cat>
-            <c:strRef>
-              <c:f>Sheet1!$A$2:$A$24</c:f>
-              <c:strCache>
-                <c:ptCount val="23"/>
-                <c:pt idx="0">
-                  <c:v>Aug 2024</c:v>
-                </c:pt>
-                <c:pt idx="1">
-                  <c:v>Sep 2024</c:v>
-                </c:pt>
-                <c:pt idx="2">
-                  <c:v>Oct 2024</c:v>
-                </c:pt>
-                <c:pt idx="3">
-                  <c:v>Nov 2024</c:v>
-                </c:pt>
-                <c:pt idx="4">
-                  <c:v>Dec 2024</c:v>
-                </c:pt>
-                <c:pt idx="5">
-                  <c:v>Jan 2025</c:v>
-                </c:pt>
-                <c:pt idx="6">
-                  <c:v>Feb 2025</c:v>
-                </c:pt>
-                <c:pt idx="7">
-                  <c:v>Mar 2025</c:v>
-                </c:pt>
-                <c:pt idx="8">
-                  <c:v>Apr 2025</c:v>
-                </c:pt>
-                <c:pt idx="9">
-                  <c:v>May 2025</c:v>
-                </c:pt>
-                <c:pt idx="10">
-                  <c:v>Jun 2025</c:v>
-                </c:pt>
-                <c:pt idx="11">
-                  <c:v>Jul 2025</c:v>
-                </c:pt>
-                <c:pt idx="12">
-                  <c:v>Aug 2025</c:v>
-                </c:pt>
-                <c:pt idx="13">
-                  <c:v>Sep 2025</c:v>
-                </c:pt>
-                <c:pt idx="14">
-                  <c:v>Oct 2025</c:v>
-                </c:pt>
-                <c:pt idx="15">
-                  <c:v>Nov 2025</c:v>
-                </c:pt>
-                <c:pt idx="16">
-                  <c:v>Dec 2025</c:v>
-                </c:pt>
-                <c:pt idx="17">
-                  <c:v>Jan 2026</c:v>
-                </c:pt>
-                <c:pt idx="18">
-                  <c:v>Feb 2026</c:v>
-                </c:pt>
-                <c:pt idx="19">
-                  <c:v>Mar 2026</c:v>
-                </c:pt>
-                <c:pt idx="20">
-                  <c:v>Apr 2026</c:v>
-                </c:pt>
-                <c:pt idx="21">
-                  <c:v>May 2026</c:v>
-                </c:pt>
-                <c:pt idx="22">
-                  <c:v>Jun 2026</c:v>
-                </c:pt>
-              </c:strCache>
-            </c:strRef>
-          </c:cat>
-          <c:val>
-            <c:numRef>
-              <c:f>Sheet1!$B$2:$B$24</c:f>
-              <c:numCache>
-                <c:formatCode>General</c:formatCode>
-                <c:ptCount val="23"/>
-                <c:pt idx="0">
-                  <c:v>0</c:v>
-                </c:pt>
-                <c:pt idx="1">
-                  <c:v>50</c:v>
-                </c:pt>
-                <c:pt idx="2">
-                  <c:v>95</c:v>
-                </c:pt>
-                <c:pt idx="3">
-                  <c:v>105</c:v>
-                </c:pt>
-                <c:pt idx="4">
-                  <c:v>65</c:v>
-                </c:pt>
-                <c:pt idx="5">
-                  <c:v>110</c:v>
-                </c:pt>
-                <c:pt idx="6">
-                  <c:v>135</c:v>
-                </c:pt>
-                <c:pt idx="7">
-                  <c:v>125</c:v>
-                </c:pt>
-                <c:pt idx="8">
-                  <c:v>150</c:v>
-                </c:pt>
-                <c:pt idx="9">
-                  <c:v>245</c:v>
-                </c:pt>
-                <c:pt idx="10">
-                  <c:v>220</c:v>
-                </c:pt>
-                <c:pt idx="11">
-                  <c:v>230</c:v>
-                </c:pt>
-                <c:pt idx="12">
-                  <c:v>240</c:v>
-                </c:pt>
-                <c:pt idx="13">
-                  <c:v>265</c:v>
-                </c:pt>
-                <c:pt idx="14">
-                  <c:v>230</c:v>
-                </c:pt>
-                <c:pt idx="15">
-                  <c:v>300</c:v>
-                </c:pt>
-                <c:pt idx="16">
-                  <c:v>190</c:v>
-                </c:pt>
-                <c:pt idx="17">
-                  <c:v>210</c:v>
-                </c:pt>
-                <c:pt idx="18">
-                  <c:v>340</c:v>
-                </c:pt>
-                <c:pt idx="19">
-                  <c:v>280</c:v>
-                </c:pt>
-                <c:pt idx="20">
-                  <c:v>220</c:v>
-                </c:pt>
-                <c:pt idx="21">
-                  <c:v>305</c:v>
-                </c:pt>
-                <c:pt idx="22">
-                  <c:v>310</c:v>
-                </c:pt>
-              </c:numCache>
-            </c:numRef>
-          </c:val>
-          <c:smooth val="0"/>
-        </c:ser>
-        <c:dLbls>
-          <c:numFmt formatCode="#,##0" sourceLinked="0"/>
-          <c:txPr>
-            <a:bodyPr/>
-            <a:lstStyle/>
-            <a:p>
-              <a:pPr>
-                <a:defRPr b="0" i="0" strike="noStrike" sz="1200" u="none">
-                  <a:solidFill>
-                    <a:srgbClr val="000000"/>
-                  </a:solidFill>
-                  <a:latin typeface="Arial"/>
-                </a:defRPr>
-              </a:pPr>
-            </a:p>
-          </c:txPr>
-          <c:showLegendKey val="0"/>
-          <c:showVal val="0"/>
-          <c:showCatName val="0"/>
-          <c:showSerName val="0"/>
-          <c:showPercent val="0"/>
-          <c:showBubbleSize val="0"/>
-          <c:showLeaderLines val="0"/>
-        </c:dLbls>
-        <c:marker val="1"/>
-        <c:axId val="2094734554"/>
-        <c:axId val="2094734552"/>
-        <c:axId val="2094734556"/>
-      </c:lineChart>
-      <c:catAx>
-        <c:axId val="2094734554"/>
-        <c:scaling>
-          <c:orientation val="minMax"/>
-        </c:scaling>
-        <c:delete val="0"/>
-        <c:axPos val="b"/>
-        <c:numFmt formatCode="General" sourceLinked="1"/>
-        <c:majorTickMark val="out"/>
-        <c:minorTickMark val="none"/>
-        <c:tickLblPos val="low"/>
-        <c:spPr>
-          <a:ln w="12700" cap="flat">
-            <a:solidFill>
-              <a:srgbClr val="888888"/>
-            </a:solidFill>
-            <a:prstDash val="solid"/>
-            <a:round/>
-          </a:ln>
-        </c:spPr>
-        <c:txPr>
-          <a:bodyPr/>
-          <a:lstStyle/>
-          <a:p>
-            <a:pPr>
-              <a:defRPr sz="1000" b="0" i="0" u="none" strike="noStrike">
-                <a:solidFill>
-                  <a:srgbClr val="4A5568"/>
-                </a:solidFill>
-                <a:latin typeface="+mn-lt"/>
-              </a:defRPr>
-            </a:pPr>
-            <a:endParaRPr lang="en-US"/>
-          </a:p>
-        </c:txPr>
-        <c:crossAx val="2094734552"/>
-        <c:crosses val="autoZero"/>
-        <c:auto val="1"/>
-        <c:lblAlgn val="ctr"/>
-        <c:noMultiLvlLbl val="0"/>
-        <c:tickLblSkip val="5"/>
-      </c:catAx>
-      <c:valAx>
-        <c:axId val="2094734552"/>
-        <c:scaling>
-          <c:orientation val="minMax"/>
-          <c:max val="350"/>
-          <c:min val="0"/>
-        </c:scaling>
-        <c:delete val="0"/>
-        <c:axPos val="l"/>
-        <c:majorGridlines>
-          <c:spPr>
-            <a:ln w="9525" cap="flat">
-              <a:solidFill>
-                <a:srgbClr val="DCE3EE"/>
-              </a:solidFill>
-              <a:prstDash val="solid"/>
-              <a:round/>
-            </a:ln>
-          </c:spPr>
-        </c:majorGridlines>
-        <c:numFmt formatCode="General" sourceLinked="0"/>
-        <c:majorTickMark val="out"/>
-        <c:minorTickMark val="none"/>
-        <c:tickLblPos val="nextTo"/>
-        <c:spPr>
-          <a:ln w="12700" cap="flat">
-            <a:solidFill>
-              <a:srgbClr val="888888"/>
-            </a:solidFill>
-            <a:prstDash val="solid"/>
-            <a:round/>
-          </a:ln>
-        </c:spPr>
-        <c:txPr>
-          <a:bodyPr/>
-          <a:lstStyle/>
-          <a:p>
-            <a:pPr>
-              <a:defRPr sz="1000" b="0" i="0" u="none" strike="noStrike">
-                <a:solidFill>
-                  <a:srgbClr val="4A5568"/>
-                </a:solidFill>
-                <a:latin typeface="+mn-lt"/>
-              </a:defRPr>
-            </a:pPr>
-            <a:endParaRPr lang="en-US"/>
-          </a:p>
-        </c:txPr>
-        <c:crossAx val="2094734554"/>
-        <c:crosses val="autoZero"/>
-        <c:crossBetween val="between"/>
-        <c:majorUnit val="100"/>
-      </c:valAx>
-      <c:spPr>
-        <a:noFill/>
-        <a:ln>
-          <a:noFill/>
-        </a:ln>
-        <a:effectLst/>
-      </c:spPr>
-    </c:plotArea>
-    <c:plotVisOnly val="1"/>
-    <c:dispBlanksAs val="span"/>
-  </c:chart>
-  <c:spPr>
-    <a:noFill/>
-    <a:ln>
-      <a:noFill/>
-    </a:ln>
-    <a:effectLst/>
-  </c:spPr>
-  <c:externalData r:id="rId1">
-    <c:autoUpdate val="0"/>
-  </c:externalData>
-</c:chartSpace>
-</file>
-
-<file path=ppt/charts/chart2.xml><?xml version="1.0" encoding="utf-8"?>
-<c:chartSpace xmlns:c="http://schemas.openxmlformats.org/drawingml/2006/chart" xmlns:a="http://schemas.openxmlformats.org/drawingml/2006/main" xmlns:r="http://schemas.openxmlformats.org/officeDocument/2006/relationships">
-  <c:date1904 val="0"/>
-  <c:roundedCorners val="1"/>
-  <c:chart>
-    <c:autoTitleDeleted val="1"/>
-    <c:plotArea>
-      <c:layout/>
-      <c:barChart>
-        <c:barDir val="col"/>
-        <c:grouping val="clustered"/>
-        <c:varyColors val="0"/>
-        <c:ser>
-          <c:idx val="0"/>
-          <c:order val="0"/>
-          <c:tx>
-            <c:strRef>
-              <c:f>Sheet1!$B$1</c:f>
-              <c:strCache>
-                <c:ptCount val="1"/>
-                <c:pt idx="0">
-                  <c:v>Unique users</c:v>
-                </c:pt>
-              </c:strCache>
-            </c:strRef>
-          </c:tx>
-          <c:spPr>
-            <a:solidFill>
-              <a:srgbClr val="0085CA"/>
-            </a:solidFill>
-            <a:effectLst/>
-          </c:spPr>
-          <c:invertIfNegative val="0"/>
-          <c:dLbls>
-            <c:numFmt formatCode="#,##0" sourceLinked="0"/>
-            <c:txPr>
-              <a:bodyPr/>
-              <a:lstStyle/>
-              <a:p>
-                <a:pPr>
-                  <a:defRPr b="0" i="0" strike="noStrike" sz="1000" u="none">
-                    <a:solidFill>
-                      <a:srgbClr val="00205B"/>
-                    </a:solidFill>
-                    <a:latin typeface="+mn-lt"/>
-                  </a:defRPr>
-                </a:pPr>
-              </a:p>
-            </c:txPr>
-            <c:showLegendKey val="0"/>
-            <c:showVal val="1"/>
-            <c:showCatName val="0"/>
-            <c:showSerName val="0"/>
-            <c:showPercent val="0"/>
-            <c:showBubbleSize val="0"/>
-            <c:showLeaderLines val="0"/>
-          </c:dLbls>
-          <c:cat>
-            <c:strRef>
-              <c:f>Sheet1!$A$2:$A$8</c:f>
-              <c:strCache>
-                <c:ptCount val="7"/>
-                <c:pt idx="0">
-                  <c:v>B</c:v>
-                </c:pt>
-                <c:pt idx="1">
-                  <c:v>O</c:v>
-                </c:pt>
-                <c:pt idx="2">
-                  <c:v>P</c:v>
-                </c:pt>
-                <c:pt idx="3">
-                  <c:v>A</c:v>
-                </c:pt>
-                <c:pt idx="4">
-                  <c:v>L</c:v>
-                </c:pt>
-                <c:pt idx="5">
-                  <c:v>S</c:v>
-                </c:pt>
-                <c:pt idx="6">
-                  <c:v>K</c:v>
-                </c:pt>
-              </c:strCache>
-            </c:strRef>
-          </c:cat>
-          <c:val>
-            <c:numRef>
-              <c:f>Sheet1!$B$2:$B$8</c:f>
-              <c:numCache>
-                <c:formatCode>General</c:formatCode>
-                <c:ptCount val="7"/>
-                <c:pt idx="0">
-                  <c:v>345</c:v>
-                </c:pt>
-                <c:pt idx="1">
-                  <c:v>120</c:v>
-                </c:pt>
-                <c:pt idx="2">
-                  <c:v>95</c:v>
-                </c:pt>
-                <c:pt idx="3">
-                  <c:v>60</c:v>
-                </c:pt>
-                <c:pt idx="4">
-                  <c:v>55</c:v>
-                </c:pt>
-                <c:pt idx="5">
-                  <c:v>55</c:v>
-                </c:pt>
-                <c:pt idx="6">
-                  <c:v>50</c:v>
-                </c:pt>
-              </c:numCache>
-            </c:numRef>
-          </c:val>
-        </c:ser>
-        <c:dLbls>
-          <c:numFmt formatCode="#,##0" sourceLinked="0"/>
-          <c:txPr>
-            <a:bodyPr/>
-            <a:lstStyle/>
-            <a:p>
-              <a:pPr>
-                <a:defRPr b="0" i="0" strike="noStrike" sz="1000" u="none">
-                  <a:solidFill>
-                    <a:srgbClr val="00205B"/>
-                  </a:solidFill>
-                  <a:latin typeface="+mn-lt"/>
-                </a:defRPr>
-              </a:pPr>
-            </a:p>
-          </c:txPr>
-          <c:showLegendKey val="0"/>
-          <c:showVal val="1"/>
-          <c:showCatName val="0"/>
-          <c:showSerName val="0"/>
-          <c:showPercent val="0"/>
-          <c:showBubbleSize val="0"/>
-          <c:showLeaderLines val="0"/>
-        </c:dLbls>
-        <c:gapWidth val="45"/>
-        <c:overlap val="0"/>
-        <c:axId val="2094734554"/>
-        <c:axId val="2094734552"/>
-        <c:axId val="2094734556"/>
-      </c:barChart>
-      <c:catAx>
-        <c:axId val="2094734554"/>
-        <c:scaling>
-          <c:orientation val="minMax"/>
-        </c:scaling>
-        <c:delete val="0"/>
-        <c:axPos val="b"/>
-        <c:numFmt formatCode="General" sourceLinked="1"/>
-        <c:majorTickMark val="out"/>
-        <c:minorTickMark val="none"/>
-        <c:tickLblPos val="low"/>
-        <c:spPr>
-          <a:ln w="12700" cap="flat">
-            <a:solidFill>
-              <a:srgbClr val="888888"/>
-            </a:solidFill>
-            <a:prstDash val="solid"/>
-            <a:round/>
-          </a:ln>
-        </c:spPr>
-        <c:txPr>
-          <a:bodyPr/>
-          <a:lstStyle/>
-          <a:p>
-            <a:pPr>
-              <a:defRPr sz="1100" b="0" i="0" u="none" strike="noStrike">
-                <a:solidFill>
-                  <a:srgbClr val="4A5568"/>
-                </a:solidFill>
-                <a:latin typeface="+mn-lt"/>
-              </a:defRPr>
-            </a:pPr>
-            <a:endParaRPr lang="en-US"/>
-          </a:p>
-        </c:txPr>
-        <c:crossAx val="2094734552"/>
-        <c:crosses val="autoZero"/>
-        <c:auto val="1"/>
-        <c:lblAlgn val="ctr"/>
-        <c:noMultiLvlLbl val="0"/>
-      </c:catAx>
-      <c:valAx>
-        <c:axId val="2094734552"/>
-        <c:scaling>
-          <c:orientation val="minMax"/>
-          <c:max val="400"/>
-          <c:min val="0"/>
-        </c:scaling>
-        <c:delete val="1"/>
-        <c:axPos val="l"/>
-        <c:numFmt formatCode="General" sourceLinked="0"/>
-        <c:majorTickMark val="out"/>
-        <c:minorTickMark val="none"/>
-        <c:tickLblPos val="nextTo"/>
-        <c:spPr>
-          <a:ln w="12700" cap="flat">
-            <a:solidFill>
-              <a:srgbClr val="888888"/>
-            </a:solidFill>
-            <a:prstDash val="solid"/>
-            <a:round/>
-          </a:ln>
-        </c:spPr>
-        <c:txPr>
-          <a:bodyPr/>
-          <a:lstStyle/>
-          <a:p>
-            <a:pPr>
-              <a:defRPr sz="1200" b="0" i="0" u="none" strike="noStrike">
-                <a:solidFill>
-                  <a:srgbClr val="000000"/>
-                </a:solidFill>
-                <a:latin typeface="Arial"/>
-              </a:defRPr>
-            </a:pPr>
-            <a:endParaRPr lang="en-US"/>
-          </a:p>
-        </c:txPr>
-        <c:crossAx val="2094734554"/>
-        <c:crosses val="autoZero"/>
-        <c:crossBetween val="between"/>
-      </c:valAx>
-      <c:spPr>
-        <a:noFill/>
-        <a:ln>
-          <a:noFill/>
-        </a:ln>
-        <a:effectLst/>
-      </c:spPr>
-    </c:plotArea>
-    <c:plotVisOnly val="1"/>
-    <c:dispBlanksAs val="span"/>
-  </c:chart>
-  <c:spPr>
-    <a:noFill/>
-    <a:ln>
-      <a:noFill/>
-    </a:ln>
-    <a:effectLst/>
-  </c:spPr>
-  <c:externalData r:id="rId1">
-    <c:autoUpdate val="0"/>
-  </c:externalData>
-</c:chartSpace>
 </file>
 
 <file path=ppt/notesMasters/notesMaster1.xml><?xml version="1.0" encoding="utf-8"?>
@@ -1375,7 +740,7 @@
 Next for ERM itself is go-live and the run phase with FZR. Beyond that, the same method fits any Slate app, and really any business-built tool where the knowledge lives in configuration and nobody wrote it down. There are plenty of those in our landscape.
 So here's our ask. We'd like your support to make this playbook a standard way to move business-built tools to industrial apps. We've already aligned with [Architect] to propose it at the architecture sync. (If you have one, name the first team outside DMS.)
 To sum up: from a business-built tool to an industrial product, and a method for the next app.
-Thank you. I'm happy to take your questions.</a:t>
+Let me close by showing you ERM 2.0 itself.</a:t>
             </a:r>
             <a:endParaRPr lang="en-US" dirty="0"/>
           </a:p>
@@ -1399,6 +764,97 @@
             <a:fld id="{F7021451-1387-4CA6-816F-3879F97B5CBC}" type="slidenum">
               <a:rPr lang="en-US"/>
               <a:t>11</a:t>
+            </a:fld>
+            <a:endParaRPr lang="en-US"/>
+          </a:p>
+        </p:txBody>
+      </p:sp>
+    </p:spTree>
+    <p:extLst>
+      <p:ext uri="{BB962C8B-B14F-4D97-AF65-F5344CB8AC3E}">
+        <p14:creationId xmlns:p14="http://schemas.microsoft.com/office/powerpoint/2010/main" val="1024086991"/>
+      </p:ext>
+    </p:extLst>
+  </p:cSld>
+  <p:clrMapOvr>
+    <a:masterClrMapping/>
+  </p:clrMapOvr>
+</p:notes>
+</file>
+
+<file path=ppt/notesSlides/notesSlide12.xml><?xml version="1.0" encoding="utf-8"?>
+<p:notes xmlns:a="http://schemas.openxmlformats.org/drawingml/2006/main" xmlns:r="http://schemas.openxmlformats.org/officeDocument/2006/relationships" xmlns:p="http://schemas.openxmlformats.org/presentationml/2006/main">
+  <p:cSld>
+    <p:spTree>
+      <p:nvGrpSpPr>
+        <p:cNvPr id="1" name=""/>
+        <p:cNvGrpSpPr/>
+        <p:nvPr/>
+      </p:nvGrpSpPr>
+      <p:grpSpPr>
+        <a:xfrm>
+          <a:off x="0" y="0"/>
+          <a:ext cx="0" cy="0"/>
+          <a:chOff x="0" y="0"/>
+          <a:chExt cx="0" cy="0"/>
+        </a:xfrm>
+      </p:grpSpPr>
+      <p:sp>
+        <p:nvSpPr>
+          <p:cNvPr id="2" name="Slide Image Placeholder 1"/>
+          <p:cNvSpPr>
+            <a:spLocks noGrp="1" noRot="1" noChangeAspect="1"/>
+          </p:cNvSpPr>
+          <p:nvPr>
+            <p:ph type="sldImg"/>
+          </p:nvPr>
+        </p:nvSpPr>
+        <p:spPr/>
+      </p:sp>
+      <p:sp>
+        <p:nvSpPr>
+          <p:cNvPr id="3" name="Notes Placeholder 2"/>
+          <p:cNvSpPr>
+            <a:spLocks noGrp="1"/>
+          </p:cNvSpPr>
+          <p:nvPr>
+            <p:ph type="body" idx="1"/>
+          </p:nvPr>
+        </p:nvSpPr>
+        <p:spPr/>
+        <p:txBody>
+          <a:bodyPr/>
+          <a:lstStyle/>
+          <a:p>
+            <a:r>
+              <a:rPr lang="en-US" dirty="0"/>
+              <a:t>Play the trailer: 1 min 34 s, full screen, sound on. Let it run without talking over it. It shows sample data only and ends on "Coming soon", which matches where we are: the app isn't live yet.
+When it ends: That's ERM 2.0. Thank you, I'm happy to take your questions.
+— — —
+Before presenting: delete the poster image and play button, insert docs/trailer-storyboard/erm2-trailer-1080p.mp4 (in Google Slides, upload it to Drive first, then Insert › Video › Google Drive) and set it to play automatically. Add about 1 min 40 s to your timing.</a:t>
+            </a:r>
+            <a:endParaRPr lang="en-US" dirty="0"/>
+          </a:p>
+        </p:txBody>
+      </p:sp>
+      <p:sp>
+        <p:nvSpPr>
+          <p:cNvPr id="4" name="Slide Number Placeholder 3"/>
+          <p:cNvSpPr>
+            <a:spLocks noGrp="1"/>
+          </p:cNvSpPr>
+          <p:nvPr>
+            <p:ph type="sldNum" sz="quarter" idx="10"/>
+          </p:nvPr>
+        </p:nvSpPr>
+        <p:spPr/>
+        <p:txBody>
+          <a:bodyPr/>
+          <a:lstStyle/>
+          <a:p>
+            <a:fld id="{F7021451-1387-4CA6-816F-3879F97B5CBC}" type="slidenum">
+              <a:rPr lang="en-US"/>
+              <a:t>12</a:t>
             </a:fld>
             <a:endParaRPr lang="en-US"/>
           </a:p>
@@ -1918,10 +1374,7 @@
               <a:t>Here is the problem and the solution on one picture.
 On the left is the Slate app we inherited. It worked, but everything was tangled together: one click set off a chain reaction behind the scenes, so a small change in one place could break a dashboard somewhere else. Switching tabs was slow. And nothing was documented, so the knowledge of what it really did lived in configuration and in a few people's heads.
 We took it through the portal: an AI-assisted migration. The AI did the heavy lifting of reading the old app and listing everything it does, and we checked every single feature on the other side.
-What came out is ERM 2.0: the same app people know, but stable, faster, documented and easy to extend. Rather than describe it, let me show you.
-— — —
-Play the trailer here: 1 min 34 s, full screen, sound on. Let it run without talking over it. It shows sample data only and ends on "Coming soon", which matches where we are: the app isn't live yet.
-Before you start: have docs/trailer-storyboard/erm2-trailer-1080p.mp4 open and cued, or embed it on this slide. Add about 1 min 40 s to your timing.</a:t>
+What came out is ERM 2.0: the same app people know, but stable, faster, documented and easy to extend. And here is what that delivered.</a:t>
             </a:r>
             <a:endParaRPr lang="en-US" dirty="0"/>
           </a:p>
@@ -2009,7 +1462,7 @@
           <a:p>
             <a:r>
               <a:rPr lang="en-US" dirty="0"/>
-              <a:t>That was ERM 2.0. One PI, two developers. Every one of the hundred and five features people rely on was carried over and checked. On top of that there are eleven new ones, like custom one-pager layouts and a slideshow mode for reviews. It's faster to move around, seven security issues were found and fixed along the way, and the app went from no documentation to ten documents.
+              <a:t>One PI, two developers. Every one of the hundred and five features people rely on was carried over and checked. On top of that there are eleven new ones, like custom one-pager layouts and a slideshow mode for reviews. It's faster to move around, seven security issues were found and fixed along the way, and the app went from no documentation to ten documents.
 The number I'd like you to remember is this one: about seventy-six percent less effort than a traditional migration. Four sprints instead of roughly seventeen. That's around eighty thousand dollars saved, and roughly ten thousand a year less to maintain. These are estimates, and the basis is in the footnote.
 And it keeps paying back. Before, every change was risky. Now each feature stands on its own, so changes are quick and safe, and any team can pick it up.
 But I'd rather the business told you how it feels.
@@ -6830,6 +6283,207 @@
 </p:sld>
 </file>
 
+<file path=ppt/slides/slide12.xml><?xml version="1.0" encoding="utf-8"?>
+<p:sld xmlns:a="http://schemas.openxmlformats.org/drawingml/2006/main" xmlns:r="http://schemas.openxmlformats.org/officeDocument/2006/relationships" xmlns:p="http://schemas.openxmlformats.org/presentationml/2006/main">
+  <p:cSld name="Slide 12">
+    <p:spTree>
+      <p:nvGrpSpPr>
+        <p:cNvPr id="1" name=""/>
+        <p:cNvGrpSpPr/>
+        <p:nvPr/>
+      </p:nvGrpSpPr>
+      <p:grpSpPr>
+        <a:xfrm>
+          <a:off x="0" y="0"/>
+          <a:ext cx="0" cy="0"/>
+          <a:chOff x="0" y="0"/>
+          <a:chExt cx="0" cy="0"/>
+        </a:xfrm>
+      </p:grpSpPr>
+      <p:sp>
+        <p:nvSpPr>
+          <p:cNvPr id="2" name="criterion"/>
+          <p:cNvSpPr txBox="1"/>
+          <p:nvPr/>
+        </p:nvSpPr>
+        <p:spPr>
+          <a:xfrm>
+            <a:off x="548640" y="201168"/>
+            <a:ext cx="5486400" cy="256032"/>
+          </a:xfrm>
+          <a:prstGeom prst="rect">
+            <a:avLst/>
+          </a:prstGeom>
+          <a:noFill/>
+          <a:ln/>
+        </p:spPr>
+        <p:txBody>
+          <a:bodyPr wrap="square" lIns="0" tIns="0" rIns="0" bIns="0" rtlCol="0" anchor="t"/>
+          <a:lstStyle/>
+          <a:p>
+            <a:pPr indent="0" marL="0">
+              <a:buNone/>
+            </a:pPr>
+            <a:r>
+              <a:rPr lang="en-US" sz="1100" b="1" spc="200" kern="0" dirty="0">
+                <a:solidFill>
+                  <a:schemeClr val="accent5"/>
+                </a:solidFill>
+              </a:rPr>
+              <a:t>ERM 2.0</a:t>
+            </a:r>
+            <a:endParaRPr lang="en-US" sz="1100" dirty="0"/>
+          </a:p>
+        </p:txBody>
+      </p:sp>
+      <p:sp>
+        <p:nvSpPr>
+          <p:cNvPr id="3" name="Text 1"/>
+          <p:cNvSpPr/>
+          <p:nvPr>
+            <p:ph idx="101" type="title" hasCustomPrompt="1"/>
+          </p:nvPr>
+        </p:nvSpPr>
+        <p:spPr>
+          <a:xfrm>
+            <a:off x="548640" y="502920"/>
+            <a:ext cx="11094415" cy="822960"/>
+          </a:xfrm>
+          <a:prstGeom prst="rect">
+            <a:avLst/>
+          </a:prstGeom>
+          <a:noFill/>
+          <a:ln/>
+        </p:spPr>
+        <p:txBody>
+          <a:bodyPr wrap="square" lIns="0" tIns="0" rIns="0" bIns="0" rtlCol="0" anchor="t"/>
+          <a:lstStyle/>
+          <a:p>
+            <a:pPr algn="l" indent="0" marL="0">
+              <a:buNone/>
+            </a:pPr>
+            <a:r>
+              <a:rPr lang="en-US" sz="3600" b="1" dirty="0">
+                <a:solidFill>
+                  <a:schemeClr val="bg1"/>
+                </a:solidFill>
+              </a:rPr>
+              <a:t>See it in action</a:t>
+            </a:r>
+            <a:endParaRPr lang="en-US" sz="3600" dirty="0"/>
+          </a:p>
+        </p:txBody>
+      </p:sp>
+      <p:pic>
+        <p:nvPicPr>
+          <p:cNvPr id="4" name="trailer-poster" descr="Placeholder for the ERM 2.0 trailer video: replace with the video">    </p:cNvPr>
+          <p:cNvPicPr>
+            <a:picLocks noChangeAspect="1"/>
+          </p:cNvPicPr>
+          <p:nvPr/>
+        </p:nvPicPr>
+        <p:blipFill>
+          <a:blip r:embed="rId1"/>
+          <a:stretch>
+            <a:fillRect/>
+          </a:stretch>
+        </p:blipFill>
+        <p:spPr>
+          <a:xfrm>
+            <a:off x="1706728" y="1417320"/>
+            <a:ext cx="8778240" cy="4937760"/>
+          </a:xfrm>
+          <a:prstGeom prst="rect">
+            <a:avLst/>
+          </a:prstGeom>
+        </p:spPr>
+      </p:pic>
+      <p:sp>
+        <p:nvSpPr>
+          <p:cNvPr id="5" name="trailer-play"/>
+          <p:cNvSpPr/>
+          <p:nvPr/>
+        </p:nvSpPr>
+        <p:spPr>
+          <a:xfrm>
+            <a:off x="5592928" y="3383280"/>
+            <a:ext cx="1005840" cy="1005840"/>
+          </a:xfrm>
+          <a:prstGeom prst="ellipse">
+            <a:avLst/>
+          </a:prstGeom>
+          <a:solidFill>
+            <a:schemeClr val="bg1">
+              <a:alpha val="85000"/>
+            </a:schemeClr>
+          </a:solidFill>
+          <a:ln/>
+        </p:spPr>
+      </p:sp>
+      <p:sp>
+        <p:nvSpPr>
+          <p:cNvPr id="6" name="trailer-play-icon"/>
+          <p:cNvSpPr/>
+          <p:nvPr/>
+        </p:nvSpPr>
+        <p:spPr>
+          <a:xfrm rot="5400000">
+            <a:off x="5940400" y="3657600"/>
+            <a:ext cx="457200" cy="457200"/>
+          </a:xfrm>
+          <a:prstGeom prst="triangle">
+            <a:avLst/>
+          </a:prstGeom>
+          <a:solidFill>
+            <a:schemeClr val="accent1"/>
+          </a:solidFill>
+          <a:ln/>
+        </p:spPr>
+      </p:sp>
+      <p:sp>
+        <p:nvSpPr>
+          <p:cNvPr id="7" name="trailer-hint"/>
+          <p:cNvSpPr txBox="1"/>
+          <p:nvPr/>
+        </p:nvSpPr>
+        <p:spPr>
+          <a:xfrm>
+            <a:off x="1706728" y="6492240"/>
+            <a:ext cx="8778240" cy="320040"/>
+          </a:xfrm>
+          <a:prstGeom prst="rect">
+            <a:avLst/>
+          </a:prstGeom>
+          <a:noFill/>
+          <a:ln/>
+        </p:spPr>
+        <p:txBody>
+          <a:bodyPr wrap="square" lIns="0" tIns="0" rIns="0" bIns="0" rtlCol="0" anchor="t"/>
+          <a:lstStyle/>
+          <a:p>
+            <a:pPr algn="ctr" indent="0" marL="0">
+              <a:buNone/>
+            </a:pPr>
+            <a:r>
+              <a:rPr lang="en-US" sz="1200" i="1" dirty="0">
+                <a:solidFill>
+                  <a:schemeClr val="accent5"/>
+                </a:solidFill>
+              </a:rPr>
+              <a:t>Placeholder: replace with the trailer video (Insert › Video), 1 min 34 s</a:t>
+            </a:r>
+            <a:endParaRPr lang="en-US" sz="1200" dirty="0"/>
+          </a:p>
+        </p:txBody>
+      </p:sp>
+    </p:spTree>
+  </p:cSld>
+  <p:clrMapOvr>
+    <a:masterClrMapping/>
+  </p:clrMapOvr>
+</p:sld>
+</file>
+
 <file path=ppt/slides/slide2.xml><?xml version="1.0" encoding="utf-8"?>
 <p:sld xmlns:a="http://schemas.openxmlformats.org/drawingml/2006/main" xmlns:r="http://schemas.openxmlformats.org/officeDocument/2006/relationships" xmlns:p="http://schemas.openxmlformats.org/presentationml/2006/main">
   <p:cSld name="Slide 2">
@@ -16250,22 +15904,30 @@
           </a:p>
         </p:txBody>
       </p:sp>
-      <p:graphicFrame>
-        <p:nvGraphicFramePr>
-          <p:cNvPr id="19" name="users-trend" descr=""/>
-          <p:cNvGraphicFramePr/>
-          <p:nvPr/>
-        </p:nvGraphicFramePr>
-        <p:xfrm>
-          <a:off x="594360" y="3063240"/>
-          <a:ext cx="4480560" cy="2971800"/>
-        </p:xfrm>
-        <a:graphic xmlns:a="http://schemas.openxmlformats.org/drawingml/2006/main">
-          <a:graphicData uri="http://schemas.openxmlformats.org/drawingml/2006/chart">
-            <c:chart xmlns:c="http://schemas.openxmlformats.org/drawingml/2006/chart" r:id="rId1"/>
-          </a:graphicData>
-        </a:graphic>
-      </p:graphicFrame>
+      <p:pic>
+        <p:nvPicPr>
+          <p:cNvPr id="19" name="users-trend" descr="Animated line chart: monthly unique users grow from 0 in Aug 2024 to about 310 in Jun 2026, peaking at 340 in Feb 2026">    </p:cNvPr>
+          <p:cNvPicPr>
+            <a:picLocks noChangeAspect="1"/>
+          </p:cNvPicPr>
+          <p:nvPr/>
+        </p:nvPicPr>
+        <p:blipFill>
+          <a:blip r:embed="rId1"/>
+          <a:stretch>
+            <a:fillRect/>
+          </a:stretch>
+        </p:blipFill>
+        <p:spPr>
+          <a:xfrm>
+            <a:off x="594360" y="3108960"/>
+            <a:ext cx="4480560" cy="2971800"/>
+          </a:xfrm>
+          <a:prstGeom prst="rect">
+            <a:avLst/>
+          </a:prstGeom>
+        </p:spPr>
+      </p:pic>
       <p:sp>
         <p:nvSpPr>
           <p:cNvPr id="20" name="trend-caption"/>
@@ -16360,22 +16022,30 @@
           </a:p>
         </p:txBody>
       </p:sp>
-      <p:graphicFrame>
-        <p:nvGraphicFramePr>
-          <p:cNvPr id="23" name="org-chart" descr=""/>
-          <p:cNvGraphicFramePr/>
-          <p:nvPr/>
-        </p:nvGraphicFramePr>
-        <p:xfrm>
-          <a:off x="5394960" y="3063240"/>
-          <a:ext cx="3749040" cy="2971800"/>
-        </p:xfrm>
-        <a:graphic xmlns:a="http://schemas.openxmlformats.org/drawingml/2006/main">
-          <a:graphicData uri="http://schemas.openxmlformats.org/drawingml/2006/chart">
-            <c:chart xmlns:c="http://schemas.openxmlformats.org/drawingml/2006/chart" r:id="rId2"/>
-          </a:graphicData>
-        </a:graphic>
-      </p:graphicFrame>
+      <p:pic>
+        <p:nvPicPr>
+          <p:cNvPr id="23" name="org-chart" descr="Animated bar chart: unique users by function, B 345, O 120, P 95, A 60, L 55, S 55, K 50; each bar is highlighted in turn">    </p:cNvPr>
+          <p:cNvPicPr>
+            <a:picLocks noChangeAspect="1"/>
+          </p:cNvPicPr>
+          <p:nvPr/>
+        </p:nvPicPr>
+        <p:blipFill>
+          <a:blip r:embed="rId2"/>
+          <a:stretch>
+            <a:fillRect/>
+          </a:stretch>
+        </p:blipFill>
+        <p:spPr>
+          <a:xfrm>
+            <a:off x="5394960" y="3108960"/>
+            <a:ext cx="3749040" cy="2971800"/>
+          </a:xfrm>
+          <a:prstGeom prst="rect">
+            <a:avLst/>
+          </a:prstGeom>
+        </p:spPr>
+      </p:pic>
       <p:sp>
         <p:nvSpPr>
           <p:cNvPr id="24" name="org-caption"/>
@@ -17284,9 +16954,9 @@
                                 </p:cTn>
                               </p:par>
                               <p:par>
-                                <p:cTn id="56" presetID="22" presetClass="entr" presetSubtype="8" fill="hold" grpId="0" nodeType="withEffect">
+                                <p:cTn id="56" presetID="10" presetClass="entr" presetSubtype="0" fill="hold" grpId="0" nodeType="withEffect">
                                   <p:stCondLst>
-                                    <p:cond delay="200"/>
+                                    <p:cond delay="0"/>
                                   </p:stCondLst>
                                   <p:childTnLst>
                                     <p:set>
@@ -17307,7 +16977,7 @@
                                         <p:strVal val="visible"/>
                                       </p:to>
                                     </p:set>
-                                    <p:animEffect transition="in" filter="wipe(left)">
+                                    <p:animEffect transition="in" filter="fade">
                                       <p:cBhvr>
                                         <p:cTn id="58" dur="450"/>
                                         <p:tgtEl>

</xml_diff>